<commit_message>
Mise à jour des codes
</commit_message>
<xml_diff>
--- a/panneaux/Panneaux.pptx
+++ b/panneaux/Panneaux.pptx
@@ -6,12 +6,13 @@
   </p:sldMasterIdLst>
   <p:sldIdLst>
     <p:sldId id="263" r:id="rId2"/>
-    <p:sldId id="257" r:id="rId3"/>
-    <p:sldId id="258" r:id="rId4"/>
-    <p:sldId id="259" r:id="rId5"/>
-    <p:sldId id="260" r:id="rId6"/>
-    <p:sldId id="262" r:id="rId7"/>
-    <p:sldId id="261" r:id="rId8"/>
+    <p:sldId id="264" r:id="rId3"/>
+    <p:sldId id="257" r:id="rId4"/>
+    <p:sldId id="258" r:id="rId5"/>
+    <p:sldId id="259" r:id="rId6"/>
+    <p:sldId id="260" r:id="rId7"/>
+    <p:sldId id="262" r:id="rId8"/>
+    <p:sldId id="261" r:id="rId9"/>
   </p:sldIdLst>
   <p:sldSz cx="12192000" cy="6858000"/>
   <p:notesSz cx="6858000" cy="9144000"/>
@@ -249,7 +250,7 @@
           <a:p>
             <a:fld id="{3536E3D2-70AC-4440-A43D-16508729F170}" type="datetimeFigureOut">
               <a:rPr lang="fr-FR" smtClean="0"/>
-              <a:t>02/03/2026</a:t>
+              <a:t>06/03/2026</a:t>
             </a:fld>
             <a:endParaRPr lang="fr-FR"/>
           </a:p>
@@ -419,7 +420,7 @@
           <a:p>
             <a:fld id="{3536E3D2-70AC-4440-A43D-16508729F170}" type="datetimeFigureOut">
               <a:rPr lang="fr-FR" smtClean="0"/>
-              <a:t>02/03/2026</a:t>
+              <a:t>06/03/2026</a:t>
             </a:fld>
             <a:endParaRPr lang="fr-FR"/>
           </a:p>
@@ -599,7 +600,7 @@
           <a:p>
             <a:fld id="{3536E3D2-70AC-4440-A43D-16508729F170}" type="datetimeFigureOut">
               <a:rPr lang="fr-FR" smtClean="0"/>
-              <a:t>02/03/2026</a:t>
+              <a:t>06/03/2026</a:t>
             </a:fld>
             <a:endParaRPr lang="fr-FR"/>
           </a:p>
@@ -769,7 +770,7 @@
           <a:p>
             <a:fld id="{3536E3D2-70AC-4440-A43D-16508729F170}" type="datetimeFigureOut">
               <a:rPr lang="fr-FR" smtClean="0"/>
-              <a:t>02/03/2026</a:t>
+              <a:t>06/03/2026</a:t>
             </a:fld>
             <a:endParaRPr lang="fr-FR"/>
           </a:p>
@@ -1015,7 +1016,7 @@
           <a:p>
             <a:fld id="{3536E3D2-70AC-4440-A43D-16508729F170}" type="datetimeFigureOut">
               <a:rPr lang="fr-FR" smtClean="0"/>
-              <a:t>02/03/2026</a:t>
+              <a:t>06/03/2026</a:t>
             </a:fld>
             <a:endParaRPr lang="fr-FR"/>
           </a:p>
@@ -1247,7 +1248,7 @@
           <a:p>
             <a:fld id="{3536E3D2-70AC-4440-A43D-16508729F170}" type="datetimeFigureOut">
               <a:rPr lang="fr-FR" smtClean="0"/>
-              <a:t>02/03/2026</a:t>
+              <a:t>06/03/2026</a:t>
             </a:fld>
             <a:endParaRPr lang="fr-FR"/>
           </a:p>
@@ -1614,7 +1615,7 @@
           <a:p>
             <a:fld id="{3536E3D2-70AC-4440-A43D-16508729F170}" type="datetimeFigureOut">
               <a:rPr lang="fr-FR" smtClean="0"/>
-              <a:t>02/03/2026</a:t>
+              <a:t>06/03/2026</a:t>
             </a:fld>
             <a:endParaRPr lang="fr-FR"/>
           </a:p>
@@ -1732,7 +1733,7 @@
           <a:p>
             <a:fld id="{3536E3D2-70AC-4440-A43D-16508729F170}" type="datetimeFigureOut">
               <a:rPr lang="fr-FR" smtClean="0"/>
-              <a:t>02/03/2026</a:t>
+              <a:t>06/03/2026</a:t>
             </a:fld>
             <a:endParaRPr lang="fr-FR"/>
           </a:p>
@@ -1827,7 +1828,7 @@
           <a:p>
             <a:fld id="{3536E3D2-70AC-4440-A43D-16508729F170}" type="datetimeFigureOut">
               <a:rPr lang="fr-FR" smtClean="0"/>
-              <a:t>02/03/2026</a:t>
+              <a:t>06/03/2026</a:t>
             </a:fld>
             <a:endParaRPr lang="fr-FR"/>
           </a:p>
@@ -2104,7 +2105,7 @@
           <a:p>
             <a:fld id="{3536E3D2-70AC-4440-A43D-16508729F170}" type="datetimeFigureOut">
               <a:rPr lang="fr-FR" smtClean="0"/>
-              <a:t>02/03/2026</a:t>
+              <a:t>06/03/2026</a:t>
             </a:fld>
             <a:endParaRPr lang="fr-FR"/>
           </a:p>
@@ -2357,7 +2358,7 @@
           <a:p>
             <a:fld id="{3536E3D2-70AC-4440-A43D-16508729F170}" type="datetimeFigureOut">
               <a:rPr lang="fr-FR" smtClean="0"/>
-              <a:t>02/03/2026</a:t>
+              <a:t>06/03/2026</a:t>
             </a:fld>
             <a:endParaRPr lang="fr-FR"/>
           </a:p>
@@ -2570,7 +2571,7 @@
           <a:p>
             <a:fld id="{3536E3D2-70AC-4440-A43D-16508729F170}" type="datetimeFigureOut">
               <a:rPr lang="fr-FR" smtClean="0"/>
-              <a:t>02/03/2026</a:t>
+              <a:t>06/03/2026</a:t>
             </a:fld>
             <a:endParaRPr lang="fr-FR"/>
           </a:p>
@@ -2997,8 +2998,8 @@
         </p:blipFill>
         <p:spPr>
           <a:xfrm>
-            <a:off x="1619480" y="1200736"/>
-            <a:ext cx="1277956" cy="1277956"/>
+            <a:off x="3095354" y="1192715"/>
+            <a:ext cx="1476260" cy="1476260"/>
           </a:xfrm>
           <a:prstGeom prst="rect">
             <a:avLst/>
@@ -3027,8 +3028,8 @@
         </p:blipFill>
         <p:spPr>
           <a:xfrm>
-            <a:off x="9160444" y="1101078"/>
-            <a:ext cx="1642835" cy="1452715"/>
+            <a:off x="7331644" y="1149205"/>
+            <a:ext cx="1897758" cy="1678137"/>
           </a:xfrm>
           <a:prstGeom prst="rect">
             <a:avLst/>
@@ -3057,8 +3058,8 @@
         </p:blipFill>
         <p:spPr>
           <a:xfrm>
-            <a:off x="1700964" y="3954327"/>
-            <a:ext cx="1346852" cy="1186913"/>
+            <a:off x="1700963" y="3954327"/>
+            <a:ext cx="1555847" cy="1371090"/>
           </a:xfrm>
           <a:prstGeom prst="rect">
             <a:avLst/>
@@ -3087,8 +3088,8 @@
         </p:blipFill>
         <p:spPr>
           <a:xfrm>
-            <a:off x="5496267" y="3849366"/>
-            <a:ext cx="1502588" cy="1370975"/>
+            <a:off x="5496266" y="3849366"/>
+            <a:ext cx="1735749" cy="1583713"/>
           </a:xfrm>
           <a:prstGeom prst="rect">
             <a:avLst/>
@@ -3117,38 +3118,8 @@
         </p:blipFill>
         <p:spPr>
           <a:xfrm>
-            <a:off x="9460353" y="3784701"/>
-            <a:ext cx="1382322" cy="1484374"/>
-          </a:xfrm>
-          <a:prstGeom prst="rect">
-            <a:avLst/>
-          </a:prstGeom>
-        </p:spPr>
-      </p:pic>
-      <p:pic>
-        <p:nvPicPr>
-          <p:cNvPr id="8" name="Image 7"/>
-          <p:cNvPicPr>
-            <a:picLocks noChangeAspect="1"/>
-          </p:cNvPicPr>
-          <p:nvPr/>
-        </p:nvPicPr>
-        <p:blipFill>
-          <a:blip r:embed="rId7" cstate="print">
-            <a:extLst>
-              <a:ext uri="{28A0092B-C50C-407E-A947-70E740481C1C}">
-                <a14:useLocalDpi xmlns:a14="http://schemas.microsoft.com/office/drawing/2010/main" val="0"/>
-              </a:ext>
-            </a:extLst>
-          </a:blip>
-          <a:stretch>
-            <a:fillRect/>
-          </a:stretch>
-        </p:blipFill>
-        <p:spPr>
-          <a:xfrm>
-            <a:off x="5356357" y="1213312"/>
-            <a:ext cx="1346721" cy="1357829"/>
+            <a:off x="9460352" y="3784700"/>
+            <a:ext cx="1596821" cy="1714709"/>
           </a:xfrm>
           <a:prstGeom prst="rect">
             <a:avLst/>
@@ -3176,6 +3147,96 @@
 </file>
 
 <file path=ppt/slides/slide2.xml><?xml version="1.0" encoding="utf-8"?>
+<p:sld xmlns:a="http://schemas.openxmlformats.org/drawingml/2006/main" xmlns:r="http://schemas.openxmlformats.org/officeDocument/2006/relationships" xmlns:p="http://schemas.openxmlformats.org/presentationml/2006/main">
+  <p:cSld>
+    <p:spTree>
+      <p:nvGrpSpPr>
+        <p:cNvPr id="1" name=""/>
+        <p:cNvGrpSpPr/>
+        <p:nvPr/>
+      </p:nvGrpSpPr>
+      <p:grpSpPr>
+        <a:xfrm>
+          <a:off x="0" y="0"/>
+          <a:ext cx="0" cy="0"/>
+          <a:chOff x="0" y="0"/>
+          <a:chExt cx="0" cy="0"/>
+        </a:xfrm>
+      </p:grpSpPr>
+      <p:pic>
+        <p:nvPicPr>
+          <p:cNvPr id="2" name="Image 1"/>
+          <p:cNvPicPr>
+            <a:picLocks noChangeAspect="1"/>
+          </p:cNvPicPr>
+          <p:nvPr/>
+        </p:nvPicPr>
+        <p:blipFill>
+          <a:blip r:embed="rId2">
+            <a:extLst>
+              <a:ext uri="{28A0092B-C50C-407E-A947-70E740481C1C}">
+                <a14:useLocalDpi xmlns:a14="http://schemas.microsoft.com/office/drawing/2010/main" val="0"/>
+              </a:ext>
+            </a:extLst>
+          </a:blip>
+          <a:stretch>
+            <a:fillRect/>
+          </a:stretch>
+        </p:blipFill>
+        <p:spPr>
+          <a:xfrm>
+            <a:off x="8149233" y="2409070"/>
+            <a:ext cx="1653484" cy="1657701"/>
+          </a:xfrm>
+          <a:prstGeom prst="rect">
+            <a:avLst/>
+          </a:prstGeom>
+        </p:spPr>
+      </p:pic>
+      <p:pic>
+        <p:nvPicPr>
+          <p:cNvPr id="3" name="Image 2"/>
+          <p:cNvPicPr>
+            <a:picLocks noChangeAspect="1"/>
+          </p:cNvPicPr>
+          <p:nvPr/>
+        </p:nvPicPr>
+        <p:blipFill>
+          <a:blip r:embed="rId3">
+            <a:extLst>
+              <a:ext uri="{28A0092B-C50C-407E-A947-70E740481C1C}">
+                <a14:useLocalDpi xmlns:a14="http://schemas.microsoft.com/office/drawing/2010/main" val="0"/>
+              </a:ext>
+            </a:extLst>
+          </a:blip>
+          <a:stretch>
+            <a:fillRect/>
+          </a:stretch>
+        </p:blipFill>
+        <p:spPr>
+          <a:xfrm>
+            <a:off x="2784136" y="2366210"/>
+            <a:ext cx="1687229" cy="1699883"/>
+          </a:xfrm>
+          <a:prstGeom prst="rect">
+            <a:avLst/>
+          </a:prstGeom>
+        </p:spPr>
+      </p:pic>
+    </p:spTree>
+    <p:extLst>
+      <p:ext uri="{BB962C8B-B14F-4D97-AF65-F5344CB8AC3E}">
+        <p14:creationId xmlns:p14="http://schemas.microsoft.com/office/powerpoint/2010/main" val="1192751822"/>
+      </p:ext>
+    </p:extLst>
+  </p:cSld>
+  <p:clrMapOvr>
+    <a:masterClrMapping/>
+  </p:clrMapOvr>
+</p:sld>
+</file>
+
+<file path=ppt/slides/slide3.xml><?xml version="1.0" encoding="utf-8"?>
 <p:sld xmlns:a="http://schemas.openxmlformats.org/drawingml/2006/main" xmlns:r="http://schemas.openxmlformats.org/officeDocument/2006/relationships" xmlns:p="http://schemas.openxmlformats.org/presentationml/2006/main">
   <p:cSld>
     <p:spTree>
@@ -3242,7 +3303,7 @@
 </p:sld>
 </file>
 
-<file path=ppt/slides/slide3.xml><?xml version="1.0" encoding="utf-8"?>
+<file path=ppt/slides/slide4.xml><?xml version="1.0" encoding="utf-8"?>
 <p:sld xmlns:a="http://schemas.openxmlformats.org/drawingml/2006/main" xmlns:r="http://schemas.openxmlformats.org/officeDocument/2006/relationships" xmlns:p="http://schemas.openxmlformats.org/presentationml/2006/main">
   <p:cSld>
     <p:spTree>
@@ -3309,7 +3370,7 @@
 </p:sld>
 </file>
 
-<file path=ppt/slides/slide4.xml><?xml version="1.0" encoding="utf-8"?>
+<file path=ppt/slides/slide5.xml><?xml version="1.0" encoding="utf-8"?>
 <p:sld xmlns:a="http://schemas.openxmlformats.org/drawingml/2006/main" xmlns:r="http://schemas.openxmlformats.org/officeDocument/2006/relationships" xmlns:p="http://schemas.openxmlformats.org/presentationml/2006/main">
   <p:cSld>
     <p:spTree>
@@ -3376,7 +3437,7 @@
 </p:sld>
 </file>
 
-<file path=ppt/slides/slide5.xml><?xml version="1.0" encoding="utf-8"?>
+<file path=ppt/slides/slide6.xml><?xml version="1.0" encoding="utf-8"?>
 <p:sld xmlns:a="http://schemas.openxmlformats.org/drawingml/2006/main" xmlns:r="http://schemas.openxmlformats.org/officeDocument/2006/relationships" xmlns:p="http://schemas.openxmlformats.org/presentationml/2006/main">
   <p:cSld>
     <p:spTree>
@@ -3443,7 +3504,7 @@
 </p:sld>
 </file>
 
-<file path=ppt/slides/slide6.xml><?xml version="1.0" encoding="utf-8"?>
+<file path=ppt/slides/slide7.xml><?xml version="1.0" encoding="utf-8"?>
 <p:sld xmlns:a="http://schemas.openxmlformats.org/drawingml/2006/main" xmlns:r="http://schemas.openxmlformats.org/officeDocument/2006/relationships" xmlns:p="http://schemas.openxmlformats.org/presentationml/2006/main">
   <p:cSld>
     <p:spTree>
@@ -3510,7 +3571,7 @@
 </p:sld>
 </file>
 
-<file path=ppt/slides/slide7.xml><?xml version="1.0" encoding="utf-8"?>
+<file path=ppt/slides/slide8.xml><?xml version="1.0" encoding="utf-8"?>
 <p:sld xmlns:a="http://schemas.openxmlformats.org/drawingml/2006/main" xmlns:r="http://schemas.openxmlformats.org/officeDocument/2006/relationships" xmlns:p="http://schemas.openxmlformats.org/presentationml/2006/main">
   <p:cSld>
     <p:spTree>

</xml_diff>